<commit_message>
Follow-ups done (F1 replicates, F2 no rescue); final report + presentation complete
- results/H4.md §9, FINDINGS.md, H2_H3.md updated with F1/F2
- report/FINAL_REPORT.{md,pdf,docx}, report/LTH_Warmup_Final.pptx (rebuild: bash report/build.sh)
- analysis/h4_tables.py lists the follow-ups

Co-Authored-By: Claude Opus 5.5 <noreply@anthropic.com>
</commit_message>
<xml_diff>
--- a/report/LTH_Warmup_Final.pptx
+++ b/report/LTH_Warmup_Final.pptx
@@ -3702,7 +3702,7 @@
         <p:spPr>
           <a:xfrm>
             <a:off x="457200" y="1554480"/>
-            <a:ext cx="7223760" cy="3980371"/>
+            <a:ext cx="7223760" cy="3973732"/>
           </a:xfrm>
           <a:prstGeom prst="rect">
             <a:avLst/>
@@ -3718,7 +3718,7 @@
         <p:spPr>
           <a:xfrm>
             <a:off x="8092440" y="1600200"/>
-            <a:ext cx="3547872" cy="2514600"/>
+            <a:ext cx="3547872" cy="2240280"/>
           </a:xfrm>
           <a:prstGeom prst="rect">
             <a:avLst/>
@@ -3804,7 +3804,7 @@
         <p:spPr>
           <a:xfrm>
             <a:off x="8321040" y="2258568"/>
-            <a:ext cx="3090672" cy="1691640"/>
+            <a:ext cx="3090672" cy="1417320"/>
           </a:xfrm>
           <a:prstGeom prst="rect">
             <a:avLst/>
@@ -3832,26 +3832,7 @@
                 </a:solidFill>
                 <a:latin typeface="Calibri"/>
               </a:rPr>
-              <a:t>η = 0.1, no warmup, same θ₀:</a:t>
-            </a:r>
-          </a:p>
-          <a:p>
-            <a:pPr algn="l">
-              <a:lnSpc>
-                <a:spcPct val="105000"/>
-              </a:lnSpc>
-              <a:spcAft>
-                <a:spcPts val="500"/>
-              </a:spcAft>
-            </a:pPr>
-            <a:r>
-              <a:rPr sz="1300" b="0">
-                <a:solidFill>
-                  <a:srgbClr val="14213D"/>
-                </a:solidFill>
-                <a:latin typeface="Calibri"/>
-              </a:rPr>
-              <a:t>warm03's 6% mask 87.2%, high's own 6% mask 82.7%.</a:t>
+              <a:t>η = 0.1, no warmup, same θ₀: warm03's 6% mask 87.2%, high's own 6% mask 82.7%.</a:t>
             </a:r>
           </a:p>
           <a:p>
@@ -3883,8 +3864,8 @@
         </p:nvSpPr>
         <p:spPr>
           <a:xfrm>
-            <a:off x="8092440" y="4297680"/>
-            <a:ext cx="3547872" cy="1737360"/>
+            <a:off x="8092440" y="3977639"/>
+            <a:ext cx="3547872" cy="2057400"/>
           </a:xfrm>
           <a:prstGeom prst="rect">
             <a:avLst/>
@@ -3927,7 +3908,7 @@
         </p:nvSpPr>
         <p:spPr>
           <a:xfrm>
-            <a:off x="8321040" y="4480560"/>
+            <a:off x="8321040" y="4160520"/>
             <a:ext cx="3090672" cy="411480"/>
           </a:xfrm>
           <a:prstGeom prst="rect">
@@ -3969,8 +3950,8 @@
         </p:nvSpPr>
         <p:spPr>
           <a:xfrm>
-            <a:off x="8321040" y="4956048"/>
-            <a:ext cx="3090672" cy="914399"/>
+            <a:off x="8321040" y="4636007"/>
+            <a:ext cx="3090672" cy="1234440"/>
           </a:xfrm>
           <a:prstGeom prst="rect">
             <a:avLst/>
@@ -3998,7 +3979,26 @@
                 </a:solidFill>
                 <a:latin typeface="Calibri"/>
               </a:rPr>
-              <a:t>Spike present (S 0.24–0.34) and R₀.₂ at chance (0.18–0.20), yet the ticket wins.</a:t>
+              <a:t>Good mask: spike present, R₀.₂ at chance, ticket wins.</a:t>
+            </a:r>
+          </a:p>
+          <a:p>
+            <a:pPr algn="l">
+              <a:lnSpc>
+                <a:spcPct val="105000"/>
+              </a:lnSpc>
+              <a:spcAft>
+                <a:spcPts val="500"/>
+              </a:spcAft>
+            </a:pPr>
+            <a:r>
+              <a:rPr sz="1300" b="0">
+                <a:solidFill>
+                  <a:srgbClr val="E3E8F0"/>
+                </a:solidFill>
+                <a:latin typeface="Calibri"/>
+              </a:rPr>
+              <a:t>Bad mask + warmup: spike gone, ticket still fails (F2).</a:t>
             </a:r>
           </a:p>
         </p:txBody>
@@ -4540,7 +4540,7 @@
                           </a:solidFill>
                           <a:latin typeface="Calibri"/>
                         </a:rPr>
-                        <a:t>pending</a:t>
+                        <a:t>+0.93</a:t>
                       </a:r>
                     </a:p>
                   </a:txBody>
@@ -4563,7 +4563,7 @@
                           </a:solidFill>
                           <a:latin typeface="Calibri"/>
                         </a:rPr>
-                        <a:t>pending</a:t>
+                        <a:t>+3.54</a:t>
                       </a:r>
                     </a:p>
                   </a:txBody>
@@ -4586,7 +4586,7 @@
                           </a:solidFill>
                           <a:latin typeface="Calibri"/>
                         </a:rPr>
-                        <a:t>pending</a:t>
+                        <a:t>+4.40</a:t>
                       </a:r>
                     </a:p>
                   </a:txBody>
@@ -4609,7 +4609,7 @@
                           </a:solidFill>
                           <a:latin typeface="Calibri"/>
                         </a:rPr>
-                        <a:t>0/0</a:t>
+                        <a:t>2/3</a:t>
                       </a:r>
                     </a:p>
                   </a:txBody>
@@ -4632,7 +4632,7 @@
                           </a:solidFill>
                           <a:latin typeface="Calibri"/>
                         </a:rPr>
-                        <a:t>pending</a:t>
+                        <a:t>replicates</a:t>
                       </a:r>
                     </a:p>
                   </a:txBody>
@@ -4820,7 +4820,7 @@
                           </a:solidFill>
                           <a:latin typeface="Calibri"/>
                         </a:rPr>
-                        <a:t>pending</a:t>
+                        <a:t>−0.02</a:t>
                       </a:r>
                     </a:p>
                   </a:txBody>
@@ -4843,7 +4843,7 @@
                           </a:solidFill>
                           <a:latin typeface="Calibri"/>
                         </a:rPr>
-                        <a:t>pending</a:t>
+                        <a:t>+0.67</a:t>
                       </a:r>
                     </a:p>
                   </a:txBody>
@@ -4866,7 +4866,7 @@
                           </a:solidFill>
                           <a:latin typeface="Calibri"/>
                         </a:rPr>
-                        <a:t>pending</a:t>
+                        <a:t>+0.31</a:t>
                       </a:r>
                     </a:p>
                   </a:txBody>
@@ -4889,7 +4889,7 @@
                           </a:solidFill>
                           <a:latin typeface="Calibri"/>
                         </a:rPr>
-                        <a:t>0/0</a:t>
+                        <a:t>0/3</a:t>
                       </a:r>
                     </a:p>
                   </a:txBody>
@@ -4912,7 +4912,7 @@
                           </a:solidFill>
                           <a:latin typeface="Calibri"/>
                         </a:rPr>
-                        <a:t>pending</a:t>
+                        <a:t>mask fails</a:t>
                       </a:r>
                     </a:p>
                   </a:txBody>
@@ -5069,7 +5069,7 @@
                 </a:solidFill>
                 <a:latin typeface="Calibri"/>
               </a:rPr>
-              <a:t>Advantage pending / pending / pending pp → pending.</a:t>
+              <a:t>Advantage +0.93 / +3.54 / +4.40 pp → REPLICATES.</a:t>
             </a:r>
           </a:p>
         </p:txBody>
@@ -5216,7 +5216,7 @@
                 </a:solidFill>
                 <a:latin typeface="Calibri"/>
               </a:rPr>
-              <a:t>Ticket pending / pending / pending% vs 88.36 / 85.52 / 82.72% without warmup → pending.</a:t>
+              <a:t>Ticket 87.64 / 85.08 / 82.04% vs 88.36 / 85.52 / 82.72% without warmup → MASK FAILS.</a:t>
             </a:r>
           </a:p>
         </p:txBody>
@@ -5920,7 +5920,7 @@
                 </a:solidFill>
                 <a:latin typeface="Calibri"/>
               </a:rPr>
-              <a:t>Coincidence holds; a good mask needs no warmup to train</a:t>
+              <a:t>Coincidence holds, but warmup is not needed to train a good mask and cannot fix a bad one</a:t>
             </a:r>
           </a:p>
         </p:txBody>
@@ -6090,7 +6090,7 @@
                 </a:solidFill>
                 <a:latin typeface="Calibri"/>
               </a:rPr>
-              <a:t>Good masks win at η 0.1; SAM no effect; anchor hurts</a:t>
+              <a:t>Good masks win at η 0.1 (2 seeds); bad masks fail even with warmup</a:t>
             </a:r>
           </a:p>
         </p:txBody>
@@ -6412,7 +6412,7 @@
                 </a:solidFill>
                 <a:latin typeface="Calibri"/>
               </a:rPr>
-              <a:t>Seeds: 2 for the main conditions, 1 for high_warm, SAM and the anchor.</a:t>
+              <a:t>Seeds: 2 for the main conditions and H4(a); 1 for high_warm, SAM, the anchor and the reverse swap.</a:t>
             </a:r>
           </a:p>
           <a:p>
@@ -14604,7 +14604,7 @@
                 </a:solidFill>
                 <a:latin typeface="Calibri"/>
               </a:rPr>
-              <a:t>+3.6 and +4.8 pp: 2/3 over the bar.</a:t>
+              <a:t>+3.6 and +4.8 pp: 2/3 over the bar. Seed 1: +3.5, +4.4.</a:t>
             </a:r>
           </a:p>
         </p:txBody>
@@ -14986,7 +14986,7 @@
                 </a:solidFill>
                 <a:latin typeface="Calibri"/>
               </a:rPr>
-              <a:t>Seed 0. Ticket accuracy, (a): 89.27 / 88.91 / 87.24%.</a:t>
+              <a:t>Seed 0. Ticket accuracy, (a): 89.27 / 88.91 / 87.24%. Open circles: (a) on seed 1 (F1).</a:t>
             </a:r>
           </a:p>
         </p:txBody>

</xml_diff>

<commit_message>
Proofread final report and deck against results
- max S claim scoped (0.54 in pruning chains, 0.63 over all runs)
- IMP 'resets' (not rewinds) to θ0; cite He et al.; untested mechanism marked as such
- high-chain R_0.2 range 0.22–0.24; note different baselines in the warm03 comparison
- rewinding next step attributed correctly; uncited references removed; Paul et al. title fixed
- deck: same fixes, 'association' instead of 'correlation' on the H2 slide

Co-Authored-By: Claude Opus 5.5 <noreply@anthropic.com>
</commit_message>
<xml_diff>
--- a/report/LTH_Warmup_Final.pptx
+++ b/report/LTH_Warmup_Final.pptx
@@ -5750,7 +5750,7 @@
                 </a:solidFill>
                 <a:latin typeface="Calibri"/>
               </a:rPr>
-              <a:t>max S 0.54 ≪ 1; the early spike is not causal (H4)</a:t>
+              <a:t>max S ≤ 0.63 ≪ 1 in every run; the early spike is not causal (H4)</a:t>
             </a:r>
           </a:p>
         </p:txBody>
@@ -6654,7 +6654,7 @@
                 </a:solidFill>
                 <a:latin typeface="Calibri"/>
               </a:rPr>
-              <a:t>Learning-rate rewinding (Frankle et al. 2020), known to restore tickets at high η: does it work by fixing the mask?</a:t>
+              <a:t>Rewinding to an early iteration (Frankle et al. 2020) finds tickets without warmup: does it work by producing better masks?</a:t>
             </a:r>
           </a:p>
         </p:txBody>
@@ -6867,7 +6867,7 @@
                 </a:solidFill>
                 <a:latin typeface="Calibri"/>
               </a:rPr>
-              <a:t>Code, configs, every run and both write-ups: github.com/kneat2448/LTH-ML-final</a:t>
+              <a:t>Code, configs, every run and the full report: github.com/kneat2448/LTH-ML-final</a:t>
             </a:r>
           </a:p>
         </p:txBody>
@@ -9214,7 +9214,7 @@
                 </a:solidFill>
                 <a:latin typeface="Calibri"/>
               </a:rPr>
-              <a:t>R₀.₂ = overlap of the top-20% weights of θ₀ and θ_T (chance ≈ 0.2).</a:t>
+              <a:t>R₀.₂ = overlap of the top-20% weights at θ₀ and after training (chance ≈ 0.2).</a:t>
             </a:r>
           </a:p>
         </p:txBody>
@@ -12435,7 +12435,7 @@
                 </a:solidFill>
                 <a:latin typeface="Calibri"/>
               </a:rPr>
-              <a:t>Max S over 105 runs is 0.54; failing tickets peak at 0.16–0.54.</a:t>
+              <a:t>Max S over the 105 pruning-chain runs is 0.54 (0.63 with H4); failing tickets peak at 0.16–0.54.</a:t>
             </a:r>
           </a:p>
           <a:p>
@@ -12582,7 +12582,7 @@
                 </a:solidFill>
                 <a:latin typeface="Calibri"/>
               </a:rPr>
-              <a:t>Only the failing condition has an early spike (max at step 25 in 15/18). Correlation, not yet cause.</a:t>
+              <a:t>Only the failing condition has an early spike (max at step 25 in 15/18). An association, not yet a cause.</a:t>
             </a:r>
           </a:p>
         </p:txBody>

</xml_diff>